<commit_message>
Final deck: roadmap dates match the chart (slide 15); cite refs 3 and 12
</commit_message>
<xml_diff>
--- a/FINAL_SUBMISSION/Dermasense_VK26-IITI-HT-0050_Stage2.pptx
+++ b/FINAL_SUBMISSION/Dermasense_VK26-IITI-HT-0050_Stage2.pptx
@@ -19910,7 +19910,7 @@
                 <a:cs typeface="DM Sans Bold"/>
                 <a:sym typeface="DM Sans Bold"/>
               </a:rPr>
-              <a:t>Build &amp; Bench (Months 1 - 2)</a:t>
+              <a:t>Build &amp; Bench (Months 1–2)</a:t>
             </a:r>
           </a:p>
         </p:txBody>
@@ -20016,7 +20016,7 @@
                 <a:cs typeface="DM Sans Bold"/>
                 <a:sym typeface="DM Sans Bold"/>
               </a:rPr>
-              <a:t>Validate &amp; Demo (Months 3 - 4)</a:t>
+              <a:t>Validate &amp; Demo (Months 3–4)</a:t>
             </a:r>
           </a:p>
         </p:txBody>
@@ -20436,7 +20436,7 @@
                 <a:cs typeface="DM Sans"/>
                 <a:sym typeface="DM Sans"/>
               </a:rPr>
-              <a:t>▪  Before 4 Dec:  Build strip version 0.2 and a printed clamp; run E4 wet tests (G3) if earlier gates pass.</a:t>
+              <a:t>▪  Dec–Jan:  Build strip version 0.2 and a printed clamp, then run E4 wet tests (G3, mid-Jan) if earlier gates pass.</a:t>
             </a:r>
           </a:p>
           <a:p>
@@ -31584,7 +31584,7 @@
                 <a:cs typeface="DM Sans"/>
                 <a:sym typeface="DM Sans"/>
               </a:rPr>
-              <a:t>▪  Searched:  papers, patents and products [1, 4, 5, 14].</a:t>
+              <a:t>▪  Searched:  papers, patents and products [1, 3, 4, 5, 14].</a:t>
             </a:r>
           </a:p>
           <a:p>
@@ -42129,7 +42129,7 @@
                           <a:cs typeface="DM Sans"/>
                           <a:sym typeface="DM Sans"/>
                         </a:rPr>
-                        <a:t>datasheets</a:t>
+                        <a:t>datasheets [12]</a:t>
                       </a:r>
                       <a:endParaRPr lang="en-US" sz="1100"/>
                     </a:p>

</xml_diff>